<commit_message>
few corrections in ppt
</commit_message>
<xml_diff>
--- a/PM2.5_project_presentation.pptx
+++ b/PM2.5_project_presentation.pptx
@@ -6,26 +6,25 @@
   </p:sldMasterIdLst>
   <p:sldIdLst>
     <p:sldId id="304" r:id="rId2"/>
-    <p:sldId id="305" r:id="rId3"/>
+    <p:sldId id="312" r:id="rId3"/>
     <p:sldId id="306" r:id="rId4"/>
     <p:sldId id="307" r:id="rId5"/>
     <p:sldId id="308" r:id="rId6"/>
-    <p:sldId id="288" r:id="rId7"/>
-    <p:sldId id="291" r:id="rId8"/>
-    <p:sldId id="292" r:id="rId9"/>
-    <p:sldId id="294" r:id="rId10"/>
-    <p:sldId id="295" r:id="rId11"/>
-    <p:sldId id="296" r:id="rId12"/>
-    <p:sldId id="297" r:id="rId13"/>
-    <p:sldId id="298" r:id="rId14"/>
-    <p:sldId id="299" r:id="rId15"/>
-    <p:sldId id="302" r:id="rId16"/>
-    <p:sldId id="300" r:id="rId17"/>
-    <p:sldId id="301" r:id="rId18"/>
-    <p:sldId id="303" r:id="rId19"/>
-    <p:sldId id="261" r:id="rId20"/>
-    <p:sldId id="262" r:id="rId21"/>
-    <p:sldId id="263" r:id="rId22"/>
+    <p:sldId id="311" r:id="rId7"/>
+    <p:sldId id="310" r:id="rId8"/>
+    <p:sldId id="313" r:id="rId9"/>
+    <p:sldId id="291" r:id="rId10"/>
+    <p:sldId id="292" r:id="rId11"/>
+    <p:sldId id="294" r:id="rId12"/>
+    <p:sldId id="295" r:id="rId13"/>
+    <p:sldId id="296" r:id="rId14"/>
+    <p:sldId id="297" r:id="rId15"/>
+    <p:sldId id="298" r:id="rId16"/>
+    <p:sldId id="314" r:id="rId17"/>
+    <p:sldId id="302" r:id="rId18"/>
+    <p:sldId id="300" r:id="rId19"/>
+    <p:sldId id="301" r:id="rId20"/>
+    <p:sldId id="303" r:id="rId21"/>
   </p:sldIdLst>
   <p:sldSz cx="12192000" cy="6858000"/>
   <p:notesSz cx="6858000" cy="9144000"/>
@@ -281,7 +280,7 @@
           <a:p>
             <a:fld id="{9E260666-9807-49E6-A98F-B350F25BA116}" type="datetimeFigureOut">
               <a:rPr lang="en-IN" smtClean="0"/>
-              <a:t>17-09-2026</a:t>
+              <a:t>18-09-2026</a:t>
             </a:fld>
             <a:endParaRPr lang="en-IN"/>
           </a:p>
@@ -481,7 +480,7 @@
           <a:p>
             <a:fld id="{9E260666-9807-49E6-A98F-B350F25BA116}" type="datetimeFigureOut">
               <a:rPr lang="en-IN" smtClean="0"/>
-              <a:t>17-09-2026</a:t>
+              <a:t>18-09-2026</a:t>
             </a:fld>
             <a:endParaRPr lang="en-IN"/>
           </a:p>
@@ -691,7 +690,7 @@
           <a:p>
             <a:fld id="{9E260666-9807-49E6-A98F-B350F25BA116}" type="datetimeFigureOut">
               <a:rPr lang="en-IN" smtClean="0"/>
-              <a:t>17-09-2026</a:t>
+              <a:t>18-09-2026</a:t>
             </a:fld>
             <a:endParaRPr lang="en-IN"/>
           </a:p>
@@ -891,7 +890,7 @@
           <a:p>
             <a:fld id="{9E260666-9807-49E6-A98F-B350F25BA116}" type="datetimeFigureOut">
               <a:rPr lang="en-IN" smtClean="0"/>
-              <a:t>17-09-2026</a:t>
+              <a:t>18-09-2026</a:t>
             </a:fld>
             <a:endParaRPr lang="en-IN"/>
           </a:p>
@@ -1167,7 +1166,7 @@
           <a:p>
             <a:fld id="{9E260666-9807-49E6-A98F-B350F25BA116}" type="datetimeFigureOut">
               <a:rPr lang="en-IN" smtClean="0"/>
-              <a:t>17-09-2026</a:t>
+              <a:t>18-09-2026</a:t>
             </a:fld>
             <a:endParaRPr lang="en-IN"/>
           </a:p>
@@ -1435,7 +1434,7 @@
           <a:p>
             <a:fld id="{9E260666-9807-49E6-A98F-B350F25BA116}" type="datetimeFigureOut">
               <a:rPr lang="en-IN" smtClean="0"/>
-              <a:t>17-09-2026</a:t>
+              <a:t>18-09-2026</a:t>
             </a:fld>
             <a:endParaRPr lang="en-IN"/>
           </a:p>
@@ -1850,7 +1849,7 @@
           <a:p>
             <a:fld id="{9E260666-9807-49E6-A98F-B350F25BA116}" type="datetimeFigureOut">
               <a:rPr lang="en-IN" smtClean="0"/>
-              <a:t>17-09-2026</a:t>
+              <a:t>18-09-2026</a:t>
             </a:fld>
             <a:endParaRPr lang="en-IN"/>
           </a:p>
@@ -1992,7 +1991,7 @@
           <a:p>
             <a:fld id="{9E260666-9807-49E6-A98F-B350F25BA116}" type="datetimeFigureOut">
               <a:rPr lang="en-IN" smtClean="0"/>
-              <a:t>17-09-2026</a:t>
+              <a:t>18-09-2026</a:t>
             </a:fld>
             <a:endParaRPr lang="en-IN"/>
           </a:p>
@@ -2105,7 +2104,7 @@
           <a:p>
             <a:fld id="{9E260666-9807-49E6-A98F-B350F25BA116}" type="datetimeFigureOut">
               <a:rPr lang="en-IN" smtClean="0"/>
-              <a:t>17-09-2026</a:t>
+              <a:t>18-09-2026</a:t>
             </a:fld>
             <a:endParaRPr lang="en-IN"/>
           </a:p>
@@ -2418,7 +2417,7 @@
           <a:p>
             <a:fld id="{9E260666-9807-49E6-A98F-B350F25BA116}" type="datetimeFigureOut">
               <a:rPr lang="en-IN" smtClean="0"/>
-              <a:t>17-09-2026</a:t>
+              <a:t>18-09-2026</a:t>
             </a:fld>
             <a:endParaRPr lang="en-IN"/>
           </a:p>
@@ -2707,7 +2706,7 @@
           <a:p>
             <a:fld id="{9E260666-9807-49E6-A98F-B350F25BA116}" type="datetimeFigureOut">
               <a:rPr lang="en-IN" smtClean="0"/>
-              <a:t>17-09-2026</a:t>
+              <a:t>18-09-2026</a:t>
             </a:fld>
             <a:endParaRPr lang="en-IN"/>
           </a:p>
@@ -2950,7 +2949,7 @@
           <a:p>
             <a:fld id="{9E260666-9807-49E6-A98F-B350F25BA116}" type="datetimeFigureOut">
               <a:rPr lang="en-IN" smtClean="0"/>
-              <a:t>17-09-2026</a:t>
+              <a:t>18-09-2026</a:t>
             </a:fld>
             <a:endParaRPr lang="en-IN"/>
           </a:p>
@@ -3438,7 +3437,7 @@
           <p:cNvPr id="5" name="Picture 4">
             <a:extLst>
               <a:ext uri="{FF2B5EF4-FFF2-40B4-BE49-F238E27FC236}">
-                <a16:creationId xmlns:a16="http://schemas.microsoft.com/office/drawing/2014/main" id="{26810063-85BD-4072-A2E8-6D6E8387F6F2}"/>
+                <a16:creationId xmlns:a16="http://schemas.microsoft.com/office/drawing/2014/main" id="{EEACCD9B-E22C-4212-AA34-D367E212B36C}"/>
               </a:ext>
             </a:extLst>
           </p:cNvPr>
@@ -3472,7 +3471,7 @@
     </p:spTree>
     <p:extLst>
       <p:ext uri="{BB962C8B-B14F-4D97-AF65-F5344CB8AC3E}">
-        <p14:creationId xmlns:p14="http://schemas.microsoft.com/office/powerpoint/2010/main" val="4242758828"/>
+        <p14:creationId xmlns:p14="http://schemas.microsoft.com/office/powerpoint/2010/main" val="3529372451"/>
       </p:ext>
     </p:extLst>
   </p:cSld>
@@ -3504,7 +3503,7 @@
           <p:cNvPr id="3" name="Picture 2">
             <a:extLst>
               <a:ext uri="{FF2B5EF4-FFF2-40B4-BE49-F238E27FC236}">
-                <a16:creationId xmlns:a16="http://schemas.microsoft.com/office/drawing/2014/main" id="{299EE5CF-942A-45D3-8999-CD4B3DF62728}"/>
+                <a16:creationId xmlns:a16="http://schemas.microsoft.com/office/drawing/2014/main" id="{DB3A5E0E-69E2-41C8-915B-EE49263DD5B4}"/>
               </a:ext>
             </a:extLst>
           </p:cNvPr>
@@ -3527,8 +3526,8 @@
         </p:blipFill>
         <p:spPr>
           <a:xfrm>
-            <a:off x="0" y="381000"/>
-            <a:ext cx="12192000" cy="6096000"/>
+            <a:off x="0" y="0"/>
+            <a:ext cx="12192000" cy="6858000"/>
           </a:xfrm>
           <a:prstGeom prst="rect">
             <a:avLst/>
@@ -3538,7 +3537,7 @@
     </p:spTree>
     <p:extLst>
       <p:ext uri="{BB962C8B-B14F-4D97-AF65-F5344CB8AC3E}">
-        <p14:creationId xmlns:p14="http://schemas.microsoft.com/office/powerpoint/2010/main" val="1937929037"/>
+        <p14:creationId xmlns:p14="http://schemas.microsoft.com/office/powerpoint/2010/main" val="1378814444"/>
       </p:ext>
     </p:extLst>
   </p:cSld>
@@ -3567,10 +3566,10 @@
       </p:grpSpPr>
       <p:pic>
         <p:nvPicPr>
-          <p:cNvPr id="3" name="Picture 2">
-            <a:extLst>
-              <a:ext uri="{FF2B5EF4-FFF2-40B4-BE49-F238E27FC236}">
-                <a16:creationId xmlns:a16="http://schemas.microsoft.com/office/drawing/2014/main" id="{6647B4D6-AD05-4FE3-BF16-DC6027727E03}"/>
+          <p:cNvPr id="5" name="Picture 4">
+            <a:extLst>
+              <a:ext uri="{FF2B5EF4-FFF2-40B4-BE49-F238E27FC236}">
+                <a16:creationId xmlns:a16="http://schemas.microsoft.com/office/drawing/2014/main" id="{26810063-85BD-4072-A2E8-6D6E8387F6F2}"/>
               </a:ext>
             </a:extLst>
           </p:cNvPr>
@@ -3593,8 +3592,8 @@
         </p:blipFill>
         <p:spPr>
           <a:xfrm>
-            <a:off x="0" y="381000"/>
-            <a:ext cx="12192000" cy="6096000"/>
+            <a:off x="0" y="0"/>
+            <a:ext cx="12192000" cy="6858000"/>
           </a:xfrm>
           <a:prstGeom prst="rect">
             <a:avLst/>
@@ -3604,7 +3603,7 @@
     </p:spTree>
     <p:extLst>
       <p:ext uri="{BB962C8B-B14F-4D97-AF65-F5344CB8AC3E}">
-        <p14:creationId xmlns:p14="http://schemas.microsoft.com/office/powerpoint/2010/main" val="3534386215"/>
+        <p14:creationId xmlns:p14="http://schemas.microsoft.com/office/powerpoint/2010/main" val="4242758828"/>
       </p:ext>
     </p:extLst>
   </p:cSld>
@@ -3633,10 +3632,10 @@
       </p:grpSpPr>
       <p:pic>
         <p:nvPicPr>
-          <p:cNvPr id="5" name="Picture 4">
-            <a:extLst>
-              <a:ext uri="{FF2B5EF4-FFF2-40B4-BE49-F238E27FC236}">
-                <a16:creationId xmlns:a16="http://schemas.microsoft.com/office/drawing/2014/main" id="{0E7B9C81-5929-4276-BAF1-CD06F1B3DCFC}"/>
+          <p:cNvPr id="4" name="Picture 3">
+            <a:extLst>
+              <a:ext uri="{FF2B5EF4-FFF2-40B4-BE49-F238E27FC236}">
+                <a16:creationId xmlns:a16="http://schemas.microsoft.com/office/drawing/2014/main" id="{F218CEAA-30AB-4E95-9044-41F5651E861F}"/>
               </a:ext>
             </a:extLst>
           </p:cNvPr>
@@ -3659,8 +3658,8 @@
         </p:blipFill>
         <p:spPr>
           <a:xfrm>
-            <a:off x="457200" y="249992"/>
-            <a:ext cx="11488766" cy="6469463"/>
+            <a:off x="0" y="0"/>
+            <a:ext cx="12192000" cy="6858000"/>
           </a:xfrm>
           <a:prstGeom prst="rect">
             <a:avLst/>
@@ -3670,7 +3669,7 @@
     </p:spTree>
     <p:extLst>
       <p:ext uri="{BB962C8B-B14F-4D97-AF65-F5344CB8AC3E}">
-        <p14:creationId xmlns:p14="http://schemas.microsoft.com/office/powerpoint/2010/main" val="2595414516"/>
+        <p14:creationId xmlns:p14="http://schemas.microsoft.com/office/powerpoint/2010/main" val="1937929037"/>
       </p:ext>
     </p:extLst>
   </p:cSld>
@@ -3702,7 +3701,7 @@
           <p:cNvPr id="3" name="Picture 2">
             <a:extLst>
               <a:ext uri="{FF2B5EF4-FFF2-40B4-BE49-F238E27FC236}">
-                <a16:creationId xmlns:a16="http://schemas.microsoft.com/office/drawing/2014/main" id="{A5A8D4B7-4C8E-48C6-A23F-F56B3D6B4F12}"/>
+                <a16:creationId xmlns:a16="http://schemas.microsoft.com/office/drawing/2014/main" id="{6647B4D6-AD05-4FE3-BF16-DC6027727E03}"/>
               </a:ext>
             </a:extLst>
           </p:cNvPr>
@@ -3725,8 +3724,8 @@
         </p:blipFill>
         <p:spPr>
           <a:xfrm>
-            <a:off x="0" y="0"/>
-            <a:ext cx="12192000" cy="6858000"/>
+            <a:off x="0" y="106017"/>
+            <a:ext cx="12192000" cy="6370983"/>
           </a:xfrm>
           <a:prstGeom prst="rect">
             <a:avLst/>
@@ -3736,7 +3735,7 @@
     </p:spTree>
     <p:extLst>
       <p:ext uri="{BB962C8B-B14F-4D97-AF65-F5344CB8AC3E}">
-        <p14:creationId xmlns:p14="http://schemas.microsoft.com/office/powerpoint/2010/main" val="285340632"/>
+        <p14:creationId xmlns:p14="http://schemas.microsoft.com/office/powerpoint/2010/main" val="3534386215"/>
       </p:ext>
     </p:extLst>
   </p:cSld>
@@ -3765,10 +3764,10 @@
       </p:grpSpPr>
       <p:pic>
         <p:nvPicPr>
-          <p:cNvPr id="3" name="Picture 2">
-            <a:extLst>
-              <a:ext uri="{FF2B5EF4-FFF2-40B4-BE49-F238E27FC236}">
-                <a16:creationId xmlns:a16="http://schemas.microsoft.com/office/drawing/2014/main" id="{5FEDFD91-6996-4B4A-8957-7A82EDACB9BB}"/>
+          <p:cNvPr id="5" name="Picture 4">
+            <a:extLst>
+              <a:ext uri="{FF2B5EF4-FFF2-40B4-BE49-F238E27FC236}">
+                <a16:creationId xmlns:a16="http://schemas.microsoft.com/office/drawing/2014/main" id="{0E7B9C81-5929-4276-BAF1-CD06F1B3DCFC}"/>
               </a:ext>
             </a:extLst>
           </p:cNvPr>
@@ -3791,8 +3790,8 @@
         </p:blipFill>
         <p:spPr>
           <a:xfrm>
-            <a:off x="0" y="0"/>
-            <a:ext cx="12192000" cy="6858000"/>
+            <a:off x="457200" y="249992"/>
+            <a:ext cx="11488766" cy="6469463"/>
           </a:xfrm>
           <a:prstGeom prst="rect">
             <a:avLst/>
@@ -3802,7 +3801,7 @@
     </p:spTree>
     <p:extLst>
       <p:ext uri="{BB962C8B-B14F-4D97-AF65-F5344CB8AC3E}">
-        <p14:creationId xmlns:p14="http://schemas.microsoft.com/office/powerpoint/2010/main" val="298440194"/>
+        <p14:creationId xmlns:p14="http://schemas.microsoft.com/office/powerpoint/2010/main" val="2595414516"/>
       </p:ext>
     </p:extLst>
   </p:cSld>
@@ -3834,7 +3833,7 @@
           <p:cNvPr id="3" name="Picture 2">
             <a:extLst>
               <a:ext uri="{FF2B5EF4-FFF2-40B4-BE49-F238E27FC236}">
-                <a16:creationId xmlns:a16="http://schemas.microsoft.com/office/drawing/2014/main" id="{853F0E31-4AF9-4A38-8F8B-2761341F55EF}"/>
+                <a16:creationId xmlns:a16="http://schemas.microsoft.com/office/drawing/2014/main" id="{02CED264-3579-4881-B788-0AD48620B572}"/>
               </a:ext>
             </a:extLst>
           </p:cNvPr>
@@ -3857,8 +3856,8 @@
         </p:blipFill>
         <p:spPr>
           <a:xfrm>
-            <a:off x="374072" y="0"/>
-            <a:ext cx="11485419" cy="6858000"/>
+            <a:off x="0" y="0"/>
+            <a:ext cx="12192000" cy="6858000"/>
           </a:xfrm>
           <a:prstGeom prst="rect">
             <a:avLst/>
@@ -3868,7 +3867,7 @@
     </p:spTree>
     <p:extLst>
       <p:ext uri="{BB962C8B-B14F-4D97-AF65-F5344CB8AC3E}">
-        <p14:creationId xmlns:p14="http://schemas.microsoft.com/office/powerpoint/2010/main" val="2073176085"/>
+        <p14:creationId xmlns:p14="http://schemas.microsoft.com/office/powerpoint/2010/main" val="3412814613"/>
       </p:ext>
     </p:extLst>
   </p:cSld>
@@ -3900,7 +3899,7 @@
           <p:cNvPr id="3" name="Picture 2">
             <a:extLst>
               <a:ext uri="{FF2B5EF4-FFF2-40B4-BE49-F238E27FC236}">
-                <a16:creationId xmlns:a16="http://schemas.microsoft.com/office/drawing/2014/main" id="{E6D1B84D-0276-4757-BEA4-AE1713E59997}"/>
+                <a16:creationId xmlns:a16="http://schemas.microsoft.com/office/drawing/2014/main" id="{5FEDFD91-6996-4B4A-8957-7A82EDACB9BB}"/>
               </a:ext>
             </a:extLst>
           </p:cNvPr>
@@ -3923,8 +3922,8 @@
         </p:blipFill>
         <p:spPr>
           <a:xfrm>
-            <a:off x="207818" y="0"/>
-            <a:ext cx="11804073" cy="6858000"/>
+            <a:off x="0" y="0"/>
+            <a:ext cx="12192000" cy="6858000"/>
           </a:xfrm>
           <a:prstGeom prst="rect">
             <a:avLst/>
@@ -3934,7 +3933,7 @@
     </p:spTree>
     <p:extLst>
       <p:ext uri="{BB962C8B-B14F-4D97-AF65-F5344CB8AC3E}">
-        <p14:creationId xmlns:p14="http://schemas.microsoft.com/office/powerpoint/2010/main" val="1808860748"/>
+        <p14:creationId xmlns:p14="http://schemas.microsoft.com/office/powerpoint/2010/main" val="298440194"/>
       </p:ext>
     </p:extLst>
   </p:cSld>
@@ -3966,7 +3965,7 @@
           <p:cNvPr id="3" name="Picture 2">
             <a:extLst>
               <a:ext uri="{FF2B5EF4-FFF2-40B4-BE49-F238E27FC236}">
-                <a16:creationId xmlns:a16="http://schemas.microsoft.com/office/drawing/2014/main" id="{4CD704F5-635D-410A-86B2-FD1376F30AFE}"/>
+                <a16:creationId xmlns:a16="http://schemas.microsoft.com/office/drawing/2014/main" id="{853F0E31-4AF9-4A38-8F8B-2761341F55EF}"/>
               </a:ext>
             </a:extLst>
           </p:cNvPr>
@@ -3989,8 +3988,8 @@
         </p:blipFill>
         <p:spPr>
           <a:xfrm>
-            <a:off x="0" y="0"/>
-            <a:ext cx="12192000" cy="6858000"/>
+            <a:off x="374072" y="0"/>
+            <a:ext cx="11485419" cy="6858000"/>
           </a:xfrm>
           <a:prstGeom prst="rect">
             <a:avLst/>
@@ -4000,7 +3999,7 @@
     </p:spTree>
     <p:extLst>
       <p:ext uri="{BB962C8B-B14F-4D97-AF65-F5344CB8AC3E}">
-        <p14:creationId xmlns:p14="http://schemas.microsoft.com/office/powerpoint/2010/main" val="2872924318"/>
+        <p14:creationId xmlns:p14="http://schemas.microsoft.com/office/powerpoint/2010/main" val="2073176085"/>
       </p:ext>
     </p:extLst>
   </p:cSld>
@@ -4027,156 +4026,46 @@
           <a:chExt cx="0" cy="0"/>
         </a:xfrm>
       </p:grpSpPr>
-      <p:sp>
-        <p:nvSpPr>
-          <p:cNvPr id="2" name="Rectangle 1">
-            <a:extLst>
-              <a:ext uri="{FF2B5EF4-FFF2-40B4-BE49-F238E27FC236}">
-                <a16:creationId xmlns:a16="http://schemas.microsoft.com/office/drawing/2014/main" id="{915FB4C9-3301-4F1B-ADE2-46D72D1A9B13}"/>
-              </a:ext>
-            </a:extLst>
-          </p:cNvPr>
-          <p:cNvSpPr/>
+      <p:pic>
+        <p:nvPicPr>
+          <p:cNvPr id="3" name="Picture 2">
+            <a:extLst>
+              <a:ext uri="{FF2B5EF4-FFF2-40B4-BE49-F238E27FC236}">
+                <a16:creationId xmlns:a16="http://schemas.microsoft.com/office/drawing/2014/main" id="{E6D1B84D-0276-4757-BEA4-AE1713E59997}"/>
+              </a:ext>
+            </a:extLst>
+          </p:cNvPr>
+          <p:cNvPicPr>
+            <a:picLocks noChangeAspect="1"/>
+          </p:cNvPicPr>
           <p:nvPr/>
-        </p:nvSpPr>
+        </p:nvPicPr>
+        <p:blipFill>
+          <a:blip r:embed="rId2">
+            <a:extLst>
+              <a:ext uri="{28A0092B-C50C-407E-A947-70E740481C1C}">
+                <a14:useLocalDpi xmlns:a14="http://schemas.microsoft.com/office/drawing/2010/main" val="0"/>
+              </a:ext>
+            </a:extLst>
+          </a:blip>
+          <a:stretch>
+            <a:fillRect/>
+          </a:stretch>
+        </p:blipFill>
         <p:spPr>
           <a:xfrm>
-            <a:off x="3048000" y="212035"/>
-            <a:ext cx="6414052" cy="5355312"/>
+            <a:off x="207818" y="0"/>
+            <a:ext cx="11804073" cy="6858000"/>
           </a:xfrm>
           <a:prstGeom prst="rect">
             <a:avLst/>
           </a:prstGeom>
         </p:spPr>
-        <p:txBody>
-          <a:bodyPr wrap="square">
-            <a:spAutoFit/>
-          </a:bodyPr>
-          <a:lstStyle/>
-          <a:p>
-            <a:r>
-              <a:rPr lang="en-IN" b="0" i="0" dirty="0">
-                <a:effectLst/>
-                <a:latin typeface="Consolas" panose="020B0609020204030204" pitchFamily="49" charset="0"/>
-              </a:rPr>
-              <a:t>co Carbon monoxide mass mixing ratio </a:t>
-            </a:r>
-          </a:p>
-          <a:p>
-            <a:r>
-              <a:rPr lang="en-IN" b="0" i="0" dirty="0">
-                <a:effectLst/>
-                <a:latin typeface="Consolas" panose="020B0609020204030204" pitchFamily="49" charset="0"/>
-              </a:rPr>
-              <a:t>aermr04 Dust Aerosol (0.03 - 0.55 um) Mixing Ratio </a:t>
-            </a:r>
-          </a:p>
-          <a:p>
-            <a:r>
-              <a:rPr lang="en-IN" b="0" i="0" dirty="0">
-                <a:effectLst/>
-                <a:latin typeface="Consolas" panose="020B0609020204030204" pitchFamily="49" charset="0"/>
-              </a:rPr>
-              <a:t>aermr05 Dust Aerosol (0.55 - 0.9 um) Mixing Ratio </a:t>
-            </a:r>
-          </a:p>
-          <a:p>
-            <a:r>
-              <a:rPr lang="en-IN" b="0" i="0" dirty="0">
-                <a:effectLst/>
-                <a:latin typeface="Consolas" panose="020B0609020204030204" pitchFamily="49" charset="0"/>
-              </a:rPr>
-              <a:t>aermr06 Dust Aerosol (0.9 - 20 um) Mixing Ratio aermr09 Hydrophilic Black Carbon Aerosol Mixing Ratio </a:t>
-            </a:r>
-          </a:p>
-          <a:p>
-            <a:r>
-              <a:rPr lang="en-IN" b="0" i="0" dirty="0">
-                <a:effectLst/>
-                <a:latin typeface="Consolas" panose="020B0609020204030204" pitchFamily="49" charset="0"/>
-              </a:rPr>
-              <a:t>aermr07 Hydrophilic Organic Matter Aerosol Mixing Ratio </a:t>
-            </a:r>
-          </a:p>
-          <a:p>
-            <a:r>
-              <a:rPr lang="en-IN" b="0" i="0" dirty="0">
-                <a:effectLst/>
-                <a:latin typeface="Consolas" panose="020B0609020204030204" pitchFamily="49" charset="0"/>
-              </a:rPr>
-              <a:t>aermr10 Hydrophobic Black Carbon Aerosol Mixing Ratio </a:t>
-            </a:r>
-          </a:p>
-          <a:p>
-            <a:r>
-              <a:rPr lang="en-IN" b="0" i="0" dirty="0">
-                <a:effectLst/>
-                <a:latin typeface="Consolas" panose="020B0609020204030204" pitchFamily="49" charset="0"/>
-              </a:rPr>
-              <a:t>aermr08 Hydrophobic Organic Matter Aerosol Mixing Ratio </a:t>
-            </a:r>
-          </a:p>
-          <a:p>
-            <a:r>
-              <a:rPr lang="en-IN" b="0" i="0" dirty="0">
-                <a:effectLst/>
-                <a:latin typeface="Consolas" panose="020B0609020204030204" pitchFamily="49" charset="0"/>
-              </a:rPr>
-              <a:t>no2 Nitrogen dioxide mass mixing ratio </a:t>
-            </a:r>
-          </a:p>
-          <a:p>
-            <a:r>
-              <a:rPr lang="en-IN" b="0" i="0" dirty="0">
-                <a:effectLst/>
-                <a:latin typeface="Consolas" panose="020B0609020204030204" pitchFamily="49" charset="0"/>
-              </a:rPr>
-              <a:t>no Nitrogen monoxide mass mixing ratio </a:t>
-            </a:r>
-          </a:p>
-          <a:p>
-            <a:r>
-              <a:rPr lang="en-IN" b="0" i="0" dirty="0">
-                <a:effectLst/>
-                <a:latin typeface="Consolas" panose="020B0609020204030204" pitchFamily="49" charset="0"/>
-              </a:rPr>
-              <a:t>go3 Ozone mass mixing ratio </a:t>
-            </a:r>
-          </a:p>
-          <a:p>
-            <a:r>
-              <a:rPr lang="en-IN" b="0" i="0" dirty="0">
-                <a:effectLst/>
-                <a:latin typeface="Consolas" panose="020B0609020204030204" pitchFamily="49" charset="0"/>
-              </a:rPr>
-              <a:t>q Specific humidity </a:t>
-            </a:r>
-          </a:p>
-          <a:p>
-            <a:r>
-              <a:rPr lang="en-IN" b="0" i="0" dirty="0">
-                <a:effectLst/>
-                <a:latin typeface="Consolas" panose="020B0609020204030204" pitchFamily="49" charset="0"/>
-              </a:rPr>
-              <a:t>so2 Sulphur dioxide mass mixing ratio </a:t>
-            </a:r>
-          </a:p>
-          <a:p>
-            <a:r>
-              <a:rPr lang="en-IN" b="0" i="0" dirty="0">
-                <a:effectLst/>
-                <a:latin typeface="Consolas" panose="020B0609020204030204" pitchFamily="49" charset="0"/>
-              </a:rPr>
-              <a:t>t Temperature</a:t>
-            </a:r>
-            <a:endParaRPr lang="en-IN" dirty="0"/>
-          </a:p>
-        </p:txBody>
-      </p:sp>
+      </p:pic>
     </p:spTree>
     <p:extLst>
       <p:ext uri="{BB962C8B-B14F-4D97-AF65-F5344CB8AC3E}">
-        <p14:creationId xmlns:p14="http://schemas.microsoft.com/office/powerpoint/2010/main" val="1492982190"/>
+        <p14:creationId xmlns:p14="http://schemas.microsoft.com/office/powerpoint/2010/main" val="1808860748"/>
       </p:ext>
     </p:extLst>
   </p:cSld>
@@ -4208,7 +4097,7 @@
           <p:cNvPr id="3" name="Picture 2">
             <a:extLst>
               <a:ext uri="{FF2B5EF4-FFF2-40B4-BE49-F238E27FC236}">
-                <a16:creationId xmlns:a16="http://schemas.microsoft.com/office/drawing/2014/main" id="{C15FA3A4-2EA5-4011-9759-5A5133966B81}"/>
+                <a16:creationId xmlns:a16="http://schemas.microsoft.com/office/drawing/2014/main" id="{88D60A1D-DA70-4D04-846E-30448EA42B94}"/>
               </a:ext>
             </a:extLst>
           </p:cNvPr>
@@ -4242,7 +4131,7 @@
     </p:spTree>
     <p:extLst>
       <p:ext uri="{BB962C8B-B14F-4D97-AF65-F5344CB8AC3E}">
-        <p14:creationId xmlns:p14="http://schemas.microsoft.com/office/powerpoint/2010/main" val="1798488584"/>
+        <p14:creationId xmlns:p14="http://schemas.microsoft.com/office/powerpoint/2010/main" val="1095269959"/>
       </p:ext>
     </p:extLst>
   </p:cSld>
@@ -4269,243 +4158,46 @@
           <a:chExt cx="0" cy="0"/>
         </a:xfrm>
       </p:grpSpPr>
-      <p:sp>
-        <p:nvSpPr>
-          <p:cNvPr id="2" name="Rectangle 1">
-            <a:extLst>
-              <a:ext uri="{FF2B5EF4-FFF2-40B4-BE49-F238E27FC236}">
-                <a16:creationId xmlns:a16="http://schemas.microsoft.com/office/drawing/2014/main" id="{67158527-380B-4944-BCB4-C5E78791C39A}"/>
-              </a:ext>
-            </a:extLst>
-          </p:cNvPr>
-          <p:cNvSpPr/>
+      <p:pic>
+        <p:nvPicPr>
+          <p:cNvPr id="3" name="Picture 2">
+            <a:extLst>
+              <a:ext uri="{FF2B5EF4-FFF2-40B4-BE49-F238E27FC236}">
+                <a16:creationId xmlns:a16="http://schemas.microsoft.com/office/drawing/2014/main" id="{4CD704F5-635D-410A-86B2-FD1376F30AFE}"/>
+              </a:ext>
+            </a:extLst>
+          </p:cNvPr>
+          <p:cNvPicPr>
+            <a:picLocks noChangeAspect="1"/>
+          </p:cNvPicPr>
           <p:nvPr/>
-        </p:nvSpPr>
+        </p:nvPicPr>
+        <p:blipFill>
+          <a:blip r:embed="rId2">
+            <a:extLst>
+              <a:ext uri="{28A0092B-C50C-407E-A947-70E740481C1C}">
+                <a14:useLocalDpi xmlns:a14="http://schemas.microsoft.com/office/drawing/2010/main" val="0"/>
+              </a:ext>
+            </a:extLst>
+          </a:blip>
+          <a:stretch>
+            <a:fillRect/>
+          </a:stretch>
+        </p:blipFill>
         <p:spPr>
           <a:xfrm>
-            <a:off x="3048000" y="994058"/>
-            <a:ext cx="6096000" cy="1477328"/>
+            <a:off x="0" y="0"/>
+            <a:ext cx="12192000" cy="6858000"/>
           </a:xfrm>
           <a:prstGeom prst="rect">
             <a:avLst/>
           </a:prstGeom>
         </p:spPr>
-        <p:txBody>
-          <a:bodyPr>
-            <a:spAutoFit/>
-          </a:bodyPr>
-          <a:lstStyle/>
-          <a:p>
-            <a:r>
-              <a:rPr lang="en-IN" b="0" i="0" dirty="0">
-                <a:effectLst/>
-                <a:latin typeface="Consolas" panose="020B0609020204030204" pitchFamily="49" charset="0"/>
-              </a:rPr>
-              <a:t>co kg kg**-1 aermr04 kg kg**-1 aermr05 kg kg**-1 aermr06 kg kg**-1 aermr09 kg kg**-1 aermr07 kg kg**-1 aermr10 kg kg**-1 aermr08 kg kg**-1 no2 kg kg**-1 no kg kg**-1 go3 kg kg**-1 q kg kg**-1 so2 kg kg**-1 t K</a:t>
-            </a:r>
-            <a:endParaRPr lang="en-IN" dirty="0"/>
-          </a:p>
-        </p:txBody>
-      </p:sp>
-      <p:sp>
-        <p:nvSpPr>
-          <p:cNvPr id="3" name="Rectangle 2">
-            <a:extLst>
-              <a:ext uri="{FF2B5EF4-FFF2-40B4-BE49-F238E27FC236}">
-                <a16:creationId xmlns:a16="http://schemas.microsoft.com/office/drawing/2014/main" id="{60ADEAD3-87F0-4824-97E7-C04C137DF18D}"/>
-              </a:ext>
-            </a:extLst>
-          </p:cNvPr>
-          <p:cNvSpPr/>
-          <p:nvPr/>
-        </p:nvSpPr>
-        <p:spPr>
-          <a:xfrm>
-            <a:off x="2663687" y="2901075"/>
-            <a:ext cx="6096000" cy="3416320"/>
-          </a:xfrm>
-          <a:prstGeom prst="rect">
-            <a:avLst/>
-          </a:prstGeom>
-        </p:spPr>
-        <p:txBody>
-          <a:bodyPr wrap="square">
-            <a:spAutoFit/>
-          </a:bodyPr>
-          <a:lstStyle/>
-          <a:p>
-            <a:r>
-              <a:rPr lang="en-IN" b="0" i="0" dirty="0">
-                <a:effectLst/>
-                <a:latin typeface="Consolas" panose="020B0609020204030204" pitchFamily="49" charset="0"/>
-              </a:rPr>
-              <a:t>'time’,</a:t>
-            </a:r>
-          </a:p>
-          <a:p>
-            <a:r>
-              <a:rPr lang="en-IN" b="0" i="0" dirty="0">
-                <a:effectLst/>
-                <a:latin typeface="Consolas" panose="020B0609020204030204" pitchFamily="49" charset="0"/>
-              </a:rPr>
-              <a:t> 'number’, </a:t>
-            </a:r>
-          </a:p>
-          <a:p>
-            <a:r>
-              <a:rPr lang="en-IN" b="0" i="0" dirty="0">
-                <a:effectLst/>
-                <a:latin typeface="Consolas" panose="020B0609020204030204" pitchFamily="49" charset="0"/>
-              </a:rPr>
-              <a:t>'step’, </a:t>
-            </a:r>
-          </a:p>
-          <a:p>
-            <a:r>
-              <a:rPr lang="en-IN" b="0" i="0" dirty="0">
-                <a:effectLst/>
-                <a:latin typeface="Consolas" panose="020B0609020204030204" pitchFamily="49" charset="0"/>
-              </a:rPr>
-              <a:t>'surface’, </a:t>
-            </a:r>
-          </a:p>
-          <a:p>
-            <a:r>
-              <a:rPr lang="en-IN" b="0" i="0" dirty="0">
-                <a:effectLst/>
-                <a:latin typeface="Consolas" panose="020B0609020204030204" pitchFamily="49" charset="0"/>
-              </a:rPr>
-              <a:t>'latitude’, </a:t>
-            </a:r>
-          </a:p>
-          <a:p>
-            <a:r>
-              <a:rPr lang="en-IN" b="0" i="0" dirty="0">
-                <a:effectLst/>
-                <a:latin typeface="Consolas" panose="020B0609020204030204" pitchFamily="49" charset="0"/>
-              </a:rPr>
-              <a:t>'longitude’, </a:t>
-            </a:r>
-          </a:p>
-          <a:p>
-            <a:r>
-              <a:rPr lang="en-IN" b="0" i="0" dirty="0">
-                <a:effectLst/>
-                <a:latin typeface="Consolas" panose="020B0609020204030204" pitchFamily="49" charset="0"/>
-              </a:rPr>
-              <a:t>'</a:t>
-            </a:r>
-            <a:r>
-              <a:rPr lang="en-IN" b="0" i="0" dirty="0" err="1">
-                <a:effectLst/>
-                <a:latin typeface="Consolas" panose="020B0609020204030204" pitchFamily="49" charset="0"/>
-              </a:rPr>
-              <a:t>valid_time</a:t>
-            </a:r>
-            <a:r>
-              <a:rPr lang="en-IN" b="0" i="0" dirty="0">
-                <a:effectLst/>
-                <a:latin typeface="Consolas" panose="020B0609020204030204" pitchFamily="49" charset="0"/>
-              </a:rPr>
-              <a:t>’, </a:t>
-            </a:r>
-          </a:p>
-          <a:p>
-            <a:r>
-              <a:rPr lang="en-IN" b="0" i="0" dirty="0">
-                <a:effectLst/>
-                <a:latin typeface="Consolas" panose="020B0609020204030204" pitchFamily="49" charset="0"/>
-              </a:rPr>
-              <a:t>'u10’, </a:t>
-            </a:r>
-          </a:p>
-          <a:p>
-            <a:r>
-              <a:rPr lang="en-IN" b="0" i="0" dirty="0">
-                <a:effectLst/>
-                <a:latin typeface="Consolas" panose="020B0609020204030204" pitchFamily="49" charset="0"/>
-              </a:rPr>
-              <a:t>'v10’, </a:t>
-            </a:r>
-          </a:p>
-          <a:p>
-            <a:r>
-              <a:rPr lang="en-IN" b="0" i="0" dirty="0">
-                <a:effectLst/>
-                <a:latin typeface="Consolas" panose="020B0609020204030204" pitchFamily="49" charset="0"/>
-              </a:rPr>
-              <a:t>'d2m’, </a:t>
-            </a:r>
-          </a:p>
-          <a:p>
-            <a:r>
-              <a:rPr lang="en-IN" b="0" i="0" dirty="0">
-                <a:effectLst/>
-                <a:latin typeface="Consolas" panose="020B0609020204030204" pitchFamily="49" charset="0"/>
-              </a:rPr>
-              <a:t>'t2m’,</a:t>
-            </a:r>
-          </a:p>
-          <a:p>
-            <a:r>
-              <a:rPr lang="en-IN" b="0" i="0" dirty="0">
-                <a:effectLst/>
-                <a:latin typeface="Consolas" panose="020B0609020204030204" pitchFamily="49" charset="0"/>
-              </a:rPr>
-              <a:t> '</a:t>
-            </a:r>
-            <a:r>
-              <a:rPr lang="en-IN" b="0" i="0" dirty="0" err="1">
-                <a:effectLst/>
-                <a:latin typeface="Consolas" panose="020B0609020204030204" pitchFamily="49" charset="0"/>
-              </a:rPr>
-              <a:t>sp</a:t>
-            </a:r>
-            <a:r>
-              <a:rPr lang="en-IN" b="0" i="0" dirty="0">
-                <a:effectLst/>
-                <a:latin typeface="Consolas" panose="020B0609020204030204" pitchFamily="49" charset="0"/>
-              </a:rPr>
-              <a:t>'</a:t>
-            </a:r>
-            <a:endParaRPr lang="en-IN" dirty="0"/>
-          </a:p>
-        </p:txBody>
-      </p:sp>
+      </p:pic>
     </p:spTree>
     <p:extLst>
       <p:ext uri="{BB962C8B-B14F-4D97-AF65-F5344CB8AC3E}">
-        <p14:creationId xmlns:p14="http://schemas.microsoft.com/office/powerpoint/2010/main" val="2102745098"/>
-      </p:ext>
-    </p:extLst>
-  </p:cSld>
-  <p:clrMapOvr>
-    <a:masterClrMapping/>
-  </p:clrMapOvr>
-</p:sld>
-</file>
-
-<file path=ppt/slides/slide21.xml><?xml version="1.0" encoding="utf-8"?>
-<p:sld xmlns:a="http://schemas.openxmlformats.org/drawingml/2006/main" xmlns:r="http://schemas.openxmlformats.org/officeDocument/2006/relationships" xmlns:p="http://schemas.openxmlformats.org/presentationml/2006/main">
-  <p:cSld>
-    <p:spTree>
-      <p:nvGrpSpPr>
-        <p:cNvPr id="1" name=""/>
-        <p:cNvGrpSpPr/>
-        <p:nvPr/>
-      </p:nvGrpSpPr>
-      <p:grpSpPr>
-        <a:xfrm>
-          <a:off x="0" y="0"/>
-          <a:ext cx="0" cy="0"/>
-          <a:chOff x="0" y="0"/>
-          <a:chExt cx="0" cy="0"/>
-        </a:xfrm>
-      </p:grpSpPr>
-    </p:spTree>
-    <p:extLst>
-      <p:ext uri="{BB962C8B-B14F-4D97-AF65-F5344CB8AC3E}">
-        <p14:creationId xmlns:p14="http://schemas.microsoft.com/office/powerpoint/2010/main" val="184093500"/>
+        <p14:creationId xmlns:p14="http://schemas.microsoft.com/office/powerpoint/2010/main" val="2872924318"/>
       </p:ext>
     </p:extLst>
   </p:cSld>
@@ -4735,7 +4427,7 @@
           <p:cNvPr id="3" name="Picture 2">
             <a:extLst>
               <a:ext uri="{FF2B5EF4-FFF2-40B4-BE49-F238E27FC236}">
-                <a16:creationId xmlns:a16="http://schemas.microsoft.com/office/drawing/2014/main" id="{7CAF2AB5-3F6D-4C9C-A1F0-34B86225756C}"/>
+                <a16:creationId xmlns:a16="http://schemas.microsoft.com/office/drawing/2014/main" id="{31D39EDC-E47D-4B9E-A187-16D66D842894}"/>
               </a:ext>
             </a:extLst>
           </p:cNvPr>
@@ -4769,7 +4461,7 @@
     </p:spTree>
     <p:extLst>
       <p:ext uri="{BB962C8B-B14F-4D97-AF65-F5344CB8AC3E}">
-        <p14:creationId xmlns:p14="http://schemas.microsoft.com/office/powerpoint/2010/main" val="2967550118"/>
+        <p14:creationId xmlns:p14="http://schemas.microsoft.com/office/powerpoint/2010/main" val="1251554406"/>
       </p:ext>
     </p:extLst>
   </p:cSld>
@@ -4801,7 +4493,7 @@
           <p:cNvPr id="3" name="Picture 2">
             <a:extLst>
               <a:ext uri="{FF2B5EF4-FFF2-40B4-BE49-F238E27FC236}">
-                <a16:creationId xmlns:a16="http://schemas.microsoft.com/office/drawing/2014/main" id="{5D614C35-CBE9-428B-BC78-B76C97F2B143}"/>
+                <a16:creationId xmlns:a16="http://schemas.microsoft.com/office/drawing/2014/main" id="{7C4682CA-8390-4409-AA12-C02CC3B1EBD8}"/>
               </a:ext>
             </a:extLst>
           </p:cNvPr>
@@ -4835,7 +4527,7 @@
     </p:spTree>
     <p:extLst>
       <p:ext uri="{BB962C8B-B14F-4D97-AF65-F5344CB8AC3E}">
-        <p14:creationId xmlns:p14="http://schemas.microsoft.com/office/powerpoint/2010/main" val="2031725678"/>
+        <p14:creationId xmlns:p14="http://schemas.microsoft.com/office/powerpoint/2010/main" val="3137745152"/>
       </p:ext>
     </p:extLst>
   </p:cSld>
@@ -4864,10 +4556,10 @@
       </p:grpSpPr>
       <p:pic>
         <p:nvPicPr>
-          <p:cNvPr id="5" name="Picture 4">
-            <a:extLst>
-              <a:ext uri="{FF2B5EF4-FFF2-40B4-BE49-F238E27FC236}">
-                <a16:creationId xmlns:a16="http://schemas.microsoft.com/office/drawing/2014/main" id="{EEACCD9B-E22C-4212-AA34-D367E212B36C}"/>
+          <p:cNvPr id="3" name="Picture 2">
+            <a:extLst>
+              <a:ext uri="{FF2B5EF4-FFF2-40B4-BE49-F238E27FC236}">
+                <a16:creationId xmlns:a16="http://schemas.microsoft.com/office/drawing/2014/main" id="{9CC6068A-D05E-4A2C-BF3F-33CD8476E404}"/>
               </a:ext>
             </a:extLst>
           </p:cNvPr>
@@ -4901,7 +4593,7 @@
     </p:spTree>
     <p:extLst>
       <p:ext uri="{BB962C8B-B14F-4D97-AF65-F5344CB8AC3E}">
-        <p14:creationId xmlns:p14="http://schemas.microsoft.com/office/powerpoint/2010/main" val="3529372451"/>
+        <p14:creationId xmlns:p14="http://schemas.microsoft.com/office/powerpoint/2010/main" val="1556199111"/>
       </p:ext>
     </p:extLst>
   </p:cSld>
@@ -4933,7 +4625,7 @@
           <p:cNvPr id="3" name="Picture 2">
             <a:extLst>
               <a:ext uri="{FF2B5EF4-FFF2-40B4-BE49-F238E27FC236}">
-                <a16:creationId xmlns:a16="http://schemas.microsoft.com/office/drawing/2014/main" id="{DB3A5E0E-69E2-41C8-915B-EE49263DD5B4}"/>
+                <a16:creationId xmlns:a16="http://schemas.microsoft.com/office/drawing/2014/main" id="{5D614C35-CBE9-428B-BC78-B76C97F2B143}"/>
               </a:ext>
             </a:extLst>
           </p:cNvPr>
@@ -4967,7 +4659,7 @@
     </p:spTree>
     <p:extLst>
       <p:ext uri="{BB962C8B-B14F-4D97-AF65-F5344CB8AC3E}">
-        <p14:creationId xmlns:p14="http://schemas.microsoft.com/office/powerpoint/2010/main" val="1378814444"/>
+        <p14:creationId xmlns:p14="http://schemas.microsoft.com/office/powerpoint/2010/main" val="2031725678"/>
       </p:ext>
     </p:extLst>
   </p:cSld>

</xml_diff>